<commit_message>
Make live demo real + refresh all submission materials for the new design/pivot
B — Live site is real: Groq key on Vercel; engine returns groq/llama-3.3-70b-versatile.
Verified 61/61 tests pass against the live deployment (real engine).

C — Refreshed everything that was stale vs. the redesign + Guardian Number pivot:
- docs/03 submission package: provider-agnostic engine (Groq/Gemini/etc.), Guardian
  Number architecture, multi-recipient alerts, 61 tests; filled team = Tumo Mogame.
- docs/05 + 08 video scripts: mono UI, real free-model badge, Guardian Number, new tagline.
- scripts/build_deck.py: pure-mono palette (black/white + risk colors only), no emoji,
  serif display, Guardian Number content; regenerated docs/Aegis_Pitch_Deck.pptx.
- docs/screenshots/: 7 captured from the live site (real groq badge), 1280px.
- PROGRESS.md: remaining = record video, submit on Devpost, rehearse Round 2.

Co-Authored-By: Claude Opus 4.8 (1M context) <noreply@anthropic.com>
</commit_message>
<xml_diff>
--- a/docs/Aegis_Pitch_Deck.pptx
+++ b/docs/Aegis_Pitch_Deck.pptx
@@ -3112,7 +3112,7 @@
             <a:avLst/>
           </a:prstGeom>
           <a:solidFill>
-            <a:srgbClr val="0A0E1A"/>
+            <a:srgbClr val="000000"/>
           </a:solidFill>
           <a:ln>
             <a:noFill/>
@@ -3156,7 +3156,7 @@
             <a:avLst/>
           </a:prstGeom>
           <a:solidFill>
-            <a:srgbClr val="111726"/>
+            <a:srgbClr val="0F0F11"/>
           </a:solidFill>
           <a:ln>
             <a:noFill/>
@@ -3185,7 +3185,7 @@
             <a:r>
               <a:rPr sz="1200" b="1">
                 <a:solidFill>
-                  <a:srgbClr val="60A5FA"/>
+                  <a:srgbClr val="FFFFFF"/>
                 </a:solidFill>
                 <a:latin typeface="Segoe UI"/>
               </a:rPr>
@@ -3224,11 +3224,11 @@
             <a:r>
               <a:rPr sz="7200" b="1">
                 <a:solidFill>
-                  <a:srgbClr val="E5E9F0"/>
-                </a:solidFill>
-                <a:latin typeface="Segoe UI"/>
+                  <a:srgbClr val="FFFFFF"/>
+                </a:solidFill>
+                <a:latin typeface="Georgia"/>
               </a:rPr>
-              <a:t>🛡️ AEGIS</a:t>
+              <a:t>AEGIS</a:t>
             </a:r>
           </a:p>
         </p:txBody>
@@ -3263,9 +3263,9 @@
             <a:r>
               <a:rPr sz="3000" b="1">
                 <a:solidFill>
-                  <a:srgbClr val="60A5FA"/>
-                </a:solidFill>
-                <a:latin typeface="Segoe UI"/>
+                  <a:srgbClr val="FFFFFF"/>
+                </a:solidFill>
+                <a:latin typeface="Georgia"/>
               </a:rPr>
               <a:t>Stop scams before they happen.</a:t>
             </a:r>
@@ -3302,7 +3302,7 @@
             <a:r>
               <a:rPr sz="1600" b="0">
                 <a:solidFill>
-                  <a:srgbClr val="94A3B8"/>
+                  <a:srgbClr val="A4A4AC"/>
                 </a:solidFill>
                 <a:latin typeface="Segoe UI"/>
               </a:rPr>
@@ -3341,7 +3341,7 @@
             <a:r>
               <a:rPr sz="1300" b="0">
                 <a:solidFill>
-                  <a:srgbClr val="94A3B8"/>
+                  <a:srgbClr val="A4A4AC"/>
                 </a:solidFill>
                 <a:latin typeface="Segoe UI"/>
               </a:rPr>
@@ -3383,7 +3383,7 @@
             <a:avLst/>
           </a:prstGeom>
           <a:solidFill>
-            <a:srgbClr val="0A0E1A"/>
+            <a:srgbClr val="000000"/>
           </a:solidFill>
           <a:ln>
             <a:noFill/>
@@ -3442,7 +3442,7 @@
             <a:r>
               <a:rPr sz="2400" b="1">
                 <a:solidFill>
-                  <a:srgbClr val="E5E9F0"/>
+                  <a:srgbClr val="FFFFFF"/>
                 </a:solidFill>
                 <a:latin typeface="Segoe UI"/>
               </a:rPr>
@@ -3458,7 +3458,7 @@
             <a:r>
               <a:rPr sz="2400" b="1">
                 <a:solidFill>
-                  <a:srgbClr val="E5E9F0"/>
+                  <a:srgbClr val="FFFFFF"/>
                 </a:solidFill>
                 <a:latin typeface="Segoe UI"/>
               </a:rPr>
@@ -3497,11 +3497,11 @@
             <a:r>
               <a:rPr sz="1500" b="0">
                 <a:solidFill>
-                  <a:srgbClr val="94A3B8"/>
+                  <a:srgbClr val="A4A4AC"/>
                 </a:solidFill>
                 <a:latin typeface="Segoe UI"/>
               </a:rPr>
-              <a:t>Roadmap:  deepfake-audio model  →  bank SDK  →  on-device privacy  →  global languages</a:t>
+              <a:t>Roadmap:  Guardian Number to production  →  real payment hold  →  on-device privacy  →  bank/telco SDK</a:t>
             </a:r>
           </a:p>
         </p:txBody>
@@ -3521,7 +3521,7 @@
             <a:avLst/>
           </a:prstGeom>
           <a:solidFill>
-            <a:srgbClr val="111726"/>
+            <a:srgbClr val="0F0F11"/>
           </a:solidFill>
           <a:ln w="12700">
             <a:solidFill>
@@ -3582,11 +3582,11 @@
             <a:r>
               <a:rPr sz="2200" b="1">
                 <a:solidFill>
-                  <a:srgbClr val="60A5FA"/>
-                </a:solidFill>
-                <a:latin typeface="Segoe UI"/>
+                  <a:srgbClr val="FFFFFF"/>
+                </a:solidFill>
+                <a:latin typeface="Georgia"/>
               </a:rPr>
-              <a:t>“Scammers got an AI. It’s time the rest of us got one too.”</a:t>
+              <a:t>“Scammers got an AI. It’s time the people we love got one too.”</a:t>
             </a:r>
           </a:p>
         </p:txBody>
@@ -3621,7 +3621,7 @@
             <a:r>
               <a:rPr sz="1300" b="0">
                 <a:solidFill>
-                  <a:srgbClr val="94A3B8"/>
+                  <a:srgbClr val="A4A4AC"/>
                 </a:solidFill>
                 <a:latin typeface="Segoe UI"/>
               </a:rPr>
@@ -3663,7 +3663,7 @@
             <a:avLst/>
           </a:prstGeom>
           <a:solidFill>
-            <a:srgbClr val="0A0E1A"/>
+            <a:srgbClr val="000000"/>
           </a:solidFill>
           <a:ln>
             <a:noFill/>
@@ -3722,7 +3722,7 @@
             <a:r>
               <a:rPr sz="3200" b="1">
                 <a:solidFill>
-                  <a:srgbClr val="E5E9F0"/>
+                  <a:srgbClr val="FFFFFF"/>
                 </a:solidFill>
                 <a:latin typeface="Segoe UI"/>
               </a:rPr>
@@ -3746,7 +3746,7 @@
             <a:avLst/>
           </a:prstGeom>
           <a:solidFill>
-            <a:srgbClr val="111726"/>
+            <a:srgbClr val="0F0F11"/>
           </a:solidFill>
           <a:ln w="12700">
             <a:solidFill>
@@ -3807,7 +3807,7 @@
             <a:r>
               <a:rPr sz="2800" b="1">
                 <a:solidFill>
-                  <a:srgbClr val="E5E9F0"/>
+                  <a:srgbClr val="FFFFFF"/>
                 </a:solidFill>
                 <a:latin typeface="Segoe UI"/>
               </a:rPr>
@@ -3823,7 +3823,7 @@
             <a:r>
               <a:rPr sz="2800" b="1">
                 <a:solidFill>
-                  <a:srgbClr val="E5E9F0"/>
+                  <a:srgbClr val="FFFFFF"/>
                 </a:solidFill>
                 <a:latin typeface="Segoe UI"/>
               </a:rPr>
@@ -3839,7 +3839,7 @@
             <a:r>
               <a:rPr sz="2800" b="1">
                 <a:solidFill>
-                  <a:srgbClr val="E5E9F0"/>
+                  <a:srgbClr val="FFFFFF"/>
                 </a:solidFill>
                 <a:latin typeface="Segoe UI"/>
               </a:rPr>
@@ -3878,7 +3878,7 @@
             <a:r>
               <a:rPr sz="1800" b="0">
                 <a:solidFill>
-                  <a:srgbClr val="F59E0B"/>
+                  <a:srgbClr val="E0B448"/>
                 </a:solidFill>
                 <a:latin typeface="Segoe UI"/>
               </a:rPr>
@@ -3894,7 +3894,7 @@
             <a:r>
               <a:rPr sz="1800" b="0">
                 <a:solidFill>
-                  <a:srgbClr val="F59E0B"/>
+                  <a:srgbClr val="E0B448"/>
                 </a:solidFill>
                 <a:latin typeface="Segoe UI"/>
               </a:rPr>
@@ -3936,7 +3936,7 @@
             <a:avLst/>
           </a:prstGeom>
           <a:solidFill>
-            <a:srgbClr val="0A0E1A"/>
+            <a:srgbClr val="000000"/>
           </a:solidFill>
           <a:ln>
             <a:noFill/>
@@ -3995,7 +3995,7 @@
             <a:r>
               <a:rPr sz="2800" b="1">
                 <a:solidFill>
-                  <a:srgbClr val="E5E9F0"/>
+                  <a:srgbClr val="FFFFFF"/>
                 </a:solidFill>
                 <a:latin typeface="Segoe UI"/>
               </a:rPr>
@@ -4019,7 +4019,7 @@
             <a:avLst/>
           </a:prstGeom>
           <a:solidFill>
-            <a:srgbClr val="111726"/>
+            <a:srgbClr val="0F0F11"/>
           </a:solidFill>
           <a:ln w="12700">
             <a:solidFill>
@@ -4080,7 +4080,7 @@
             <a:r>
               <a:rPr sz="3400" b="1">
                 <a:solidFill>
-                  <a:srgbClr val="EF4444"/>
+                  <a:srgbClr val="F0613F"/>
                 </a:solidFill>
                 <a:latin typeface="Segoe UI"/>
               </a:rPr>
@@ -4119,7 +4119,7 @@
             <a:r>
               <a:rPr sz="1300" b="0">
                 <a:solidFill>
-                  <a:srgbClr val="94A3B8"/>
+                  <a:srgbClr val="A4A4AC"/>
                 </a:solidFill>
                 <a:latin typeface="Segoe UI"/>
               </a:rPr>
@@ -4143,7 +4143,7 @@
             <a:avLst/>
           </a:prstGeom>
           <a:solidFill>
-            <a:srgbClr val="111726"/>
+            <a:srgbClr val="0F0F11"/>
           </a:solidFill>
           <a:ln w="12700">
             <a:solidFill>
@@ -4204,7 +4204,7 @@
             <a:r>
               <a:rPr sz="3400" b="1">
                 <a:solidFill>
-                  <a:srgbClr val="F59E0B"/>
+                  <a:srgbClr val="E0B448"/>
                 </a:solidFill>
                 <a:latin typeface="Segoe UI"/>
               </a:rPr>
@@ -4243,7 +4243,7 @@
             <a:r>
               <a:rPr sz="1300" b="0">
                 <a:solidFill>
-                  <a:srgbClr val="94A3B8"/>
+                  <a:srgbClr val="A4A4AC"/>
                 </a:solidFill>
                 <a:latin typeface="Segoe UI"/>
               </a:rPr>
@@ -4267,7 +4267,7 @@
             <a:avLst/>
           </a:prstGeom>
           <a:solidFill>
-            <a:srgbClr val="111726"/>
+            <a:srgbClr val="0F0F11"/>
           </a:solidFill>
           <a:ln w="12700">
             <a:solidFill>
@@ -4328,7 +4328,7 @@
             <a:r>
               <a:rPr sz="3400" b="1">
                 <a:solidFill>
-                  <a:srgbClr val="F59E0B"/>
+                  <a:srgbClr val="E0B448"/>
                 </a:solidFill>
                 <a:latin typeface="Segoe UI"/>
               </a:rPr>
@@ -4367,7 +4367,7 @@
             <a:r>
               <a:rPr sz="1300" b="0">
                 <a:solidFill>
-                  <a:srgbClr val="94A3B8"/>
+                  <a:srgbClr val="A4A4AC"/>
                 </a:solidFill>
                 <a:latin typeface="Segoe UI"/>
               </a:rPr>
@@ -4391,7 +4391,7 @@
             <a:avLst/>
           </a:prstGeom>
           <a:solidFill>
-            <a:srgbClr val="111726"/>
+            <a:srgbClr val="0F0F11"/>
           </a:solidFill>
           <a:ln w="12700">
             <a:solidFill>
@@ -4452,7 +4452,7 @@
             <a:r>
               <a:rPr sz="3400" b="1">
                 <a:solidFill>
-                  <a:srgbClr val="EF4444"/>
+                  <a:srgbClr val="F0613F"/>
                 </a:solidFill>
                 <a:latin typeface="Segoe UI"/>
               </a:rPr>
@@ -4491,7 +4491,7 @@
             <a:r>
               <a:rPr sz="1300" b="0">
                 <a:solidFill>
-                  <a:srgbClr val="94A3B8"/>
+                  <a:srgbClr val="A4A4AC"/>
                 </a:solidFill>
                 <a:latin typeface="Segoe UI"/>
               </a:rPr>
@@ -4530,7 +4530,7 @@
             <a:r>
               <a:rPr sz="1800" b="1">
                 <a:solidFill>
-                  <a:srgbClr val="E5E9F0"/>
+                  <a:srgbClr val="FFFFFF"/>
                 </a:solidFill>
                 <a:latin typeface="Segoe UI"/>
               </a:rPr>
@@ -4572,7 +4572,7 @@
             <a:avLst/>
           </a:prstGeom>
           <a:solidFill>
-            <a:srgbClr val="0A0E1A"/>
+            <a:srgbClr val="000000"/>
           </a:solidFill>
           <a:ln>
             <a:noFill/>
@@ -4631,7 +4631,7 @@
             <a:r>
               <a:rPr sz="3000" b="1">
                 <a:solidFill>
-                  <a:srgbClr val="E5E9F0"/>
+                  <a:srgbClr val="FFFFFF"/>
                 </a:solidFill>
                 <a:latin typeface="Segoe UI"/>
               </a:rPr>
@@ -4655,7 +4655,7 @@
             <a:avLst/>
           </a:prstGeom>
           <a:solidFill>
-            <a:srgbClr val="111726"/>
+            <a:srgbClr val="0F0F11"/>
           </a:solidFill>
           <a:ln w="12700">
             <a:solidFill>
@@ -4716,11 +4716,11 @@
             <a:r>
               <a:rPr sz="2200" b="1">
                 <a:solidFill>
-                  <a:srgbClr val="EF4444"/>
+                  <a:srgbClr val="F0613F"/>
                 </a:solidFill>
                 <a:latin typeface="Segoe UI"/>
               </a:rPr>
-              <a:t>⏰  Reactive</a:t>
+              <a:t>Reactive</a:t>
             </a:r>
           </a:p>
         </p:txBody>
@@ -4755,7 +4755,7 @@
             <a:r>
               <a:rPr sz="1600" b="0">
                 <a:solidFill>
-                  <a:srgbClr val="94A3B8"/>
+                  <a:srgbClr val="A4A4AC"/>
                 </a:solidFill>
                 <a:latin typeface="Segoe UI"/>
               </a:rPr>
@@ -4779,7 +4779,7 @@
             <a:avLst/>
           </a:prstGeom>
           <a:solidFill>
-            <a:srgbClr val="111726"/>
+            <a:srgbClr val="0F0F11"/>
           </a:solidFill>
           <a:ln w="12700">
             <a:solidFill>
@@ -4840,11 +4840,11 @@
             <a:r>
               <a:rPr sz="2200" b="1">
                 <a:solidFill>
-                  <a:srgbClr val="EF4444"/>
+                  <a:srgbClr val="F0613F"/>
                 </a:solidFill>
                 <a:latin typeface="Segoe UI"/>
               </a:rPr>
-              <a:t>🔑  Keyword-based</a:t>
+              <a:t>Keyword-based</a:t>
             </a:r>
           </a:p>
         </p:txBody>
@@ -4879,7 +4879,7 @@
             <a:r>
               <a:rPr sz="1600" b="0">
                 <a:solidFill>
-                  <a:srgbClr val="94A3B8"/>
+                  <a:srgbClr val="A4A4AC"/>
                 </a:solidFill>
                 <a:latin typeface="Segoe UI"/>
               </a:rPr>
@@ -4903,7 +4903,7 @@
             <a:avLst/>
           </a:prstGeom>
           <a:solidFill>
-            <a:srgbClr val="111726"/>
+            <a:srgbClr val="0F0F11"/>
           </a:solidFill>
           <a:ln w="12700">
             <a:solidFill>
@@ -4964,11 +4964,11 @@
             <a:r>
               <a:rPr sz="2200" b="1">
                 <a:solidFill>
-                  <a:srgbClr val="EF4444"/>
+                  <a:srgbClr val="F0613F"/>
                 </a:solidFill>
                 <a:latin typeface="Segoe UI"/>
               </a:rPr>
-              <a:t>🕳️  No human moment</a:t>
+              <a:t>No human moment</a:t>
             </a:r>
           </a:p>
         </p:txBody>
@@ -5003,7 +5003,7 @@
             <a:r>
               <a:rPr sz="1600" b="0">
                 <a:solidFill>
-                  <a:srgbClr val="94A3B8"/>
+                  <a:srgbClr val="A4A4AC"/>
                 </a:solidFill>
                 <a:latin typeface="Segoe UI"/>
               </a:rPr>
@@ -5045,7 +5045,7 @@
             <a:avLst/>
           </a:prstGeom>
           <a:solidFill>
-            <a:srgbClr val="0A0E1A"/>
+            <a:srgbClr val="000000"/>
           </a:solidFill>
           <a:ln>
             <a:noFill/>
@@ -5104,9 +5104,9 @@
             <a:r>
               <a:rPr sz="4400" b="1">
                 <a:solidFill>
-                  <a:srgbClr val="E5E9F0"/>
-                </a:solidFill>
-                <a:latin typeface="Segoe UI"/>
+                  <a:srgbClr val="FFFFFF"/>
+                </a:solidFill>
+                <a:latin typeface="Georgia"/>
               </a:rPr>
               <a:t>Meet Aegis</a:t>
             </a:r>
@@ -5143,7 +5143,7 @@
             <a:r>
               <a:rPr sz="2200" b="1">
                 <a:solidFill>
-                  <a:srgbClr val="60A5FA"/>
+                  <a:srgbClr val="FFFFFF"/>
                 </a:solidFill>
                 <a:latin typeface="Segoe UI"/>
               </a:rPr>
@@ -5167,7 +5167,7 @@
             <a:avLst/>
           </a:prstGeom>
           <a:solidFill>
-            <a:srgbClr val="111726"/>
+            <a:srgbClr val="0F0F11"/>
           </a:solidFill>
           <a:ln w="12700">
             <a:solidFill>
@@ -5226,13 +5226,13 @@
               </a:lnSpc>
             </a:pPr>
             <a:r>
-              <a:rPr sz="4000" b="1">
-                <a:solidFill>
-                  <a:srgbClr val="E5E9F0"/>
-                </a:solidFill>
-                <a:latin typeface="Segoe UI"/>
+              <a:rPr sz="3400" b="1">
+                <a:solidFill>
+                  <a:srgbClr val="A4A4AC"/>
+                </a:solidFill>
+                <a:latin typeface="Consolas"/>
               </a:rPr>
-              <a:t>🧠</a:t>
+              <a:t>01</a:t>
             </a:r>
           </a:p>
         </p:txBody>
@@ -5267,7 +5267,7 @@
             <a:r>
               <a:rPr sz="2200" b="1">
                 <a:solidFill>
-                  <a:srgbClr val="22C55E"/>
+                  <a:srgbClr val="7FD6A6"/>
                 </a:solidFill>
                 <a:latin typeface="Segoe UI"/>
               </a:rPr>
@@ -5291,7 +5291,7 @@
             <a:avLst/>
           </a:prstGeom>
           <a:solidFill>
-            <a:srgbClr val="111726"/>
+            <a:srgbClr val="0F0F11"/>
           </a:solidFill>
           <a:ln w="12700">
             <a:solidFill>
@@ -5350,13 +5350,13 @@
               </a:lnSpc>
             </a:pPr>
             <a:r>
-              <a:rPr sz="4000" b="1">
-                <a:solidFill>
-                  <a:srgbClr val="E5E9F0"/>
-                </a:solidFill>
-                <a:latin typeface="Segoe UI"/>
+              <a:rPr sz="3400" b="1">
+                <a:solidFill>
+                  <a:srgbClr val="A4A4AC"/>
+                </a:solidFill>
+                <a:latin typeface="Consolas"/>
               </a:rPr>
-              <a:t>📢</a:t>
+              <a:t>02</a:t>
             </a:r>
           </a:p>
         </p:txBody>
@@ -5391,7 +5391,7 @@
             <a:r>
               <a:rPr sz="2200" b="1">
                 <a:solidFill>
-                  <a:srgbClr val="F59E0B"/>
+                  <a:srgbClr val="E0B448"/>
                 </a:solidFill>
                 <a:latin typeface="Segoe UI"/>
               </a:rPr>
@@ -5415,7 +5415,7 @@
             <a:avLst/>
           </a:prstGeom>
           <a:solidFill>
-            <a:srgbClr val="111726"/>
+            <a:srgbClr val="0F0F11"/>
           </a:solidFill>
           <a:ln w="12700">
             <a:solidFill>
@@ -5474,13 +5474,13 @@
               </a:lnSpc>
             </a:pPr>
             <a:r>
-              <a:rPr sz="4000" b="1">
-                <a:solidFill>
-                  <a:srgbClr val="E5E9F0"/>
-                </a:solidFill>
-                <a:latin typeface="Segoe UI"/>
+              <a:rPr sz="3400" b="1">
+                <a:solidFill>
+                  <a:srgbClr val="A4A4AC"/>
+                </a:solidFill>
+                <a:latin typeface="Consolas"/>
               </a:rPr>
-              <a:t>🛡️</a:t>
+              <a:t>03</a:t>
             </a:r>
           </a:p>
         </p:txBody>
@@ -5515,7 +5515,7 @@
             <a:r>
               <a:rPr sz="2200" b="1">
                 <a:solidFill>
-                  <a:srgbClr val="3B82F6"/>
+                  <a:srgbClr val="FFFFFF"/>
                 </a:solidFill>
                 <a:latin typeface="Segoe UI"/>
               </a:rPr>
@@ -5557,7 +5557,7 @@
             <a:avLst/>
           </a:prstGeom>
           <a:solidFill>
-            <a:srgbClr val="0A0E1A"/>
+            <a:srgbClr val="000000"/>
           </a:solidFill>
           <a:ln>
             <a:noFill/>
@@ -5616,7 +5616,7 @@
             <a:r>
               <a:rPr sz="3000" b="1">
                 <a:solidFill>
-                  <a:srgbClr val="E5E9F0"/>
+                  <a:srgbClr val="FFFFFF"/>
                 </a:solidFill>
                 <a:latin typeface="Segoe UI"/>
               </a:rPr>
@@ -5640,7 +5640,7 @@
             <a:avLst/>
           </a:prstGeom>
           <a:solidFill>
-            <a:srgbClr val="111726"/>
+            <a:srgbClr val="0F0F11"/>
           </a:solidFill>
           <a:ln w="12700">
             <a:solidFill>
@@ -5701,7 +5701,7 @@
             <a:r>
               <a:rPr sz="1800" b="1">
                 <a:solidFill>
-                  <a:srgbClr val="22C55E"/>
+                  <a:srgbClr val="7FD6A6"/>
                 </a:solidFill>
                 <a:latin typeface="Segoe UI"/>
               </a:rPr>
@@ -5717,7 +5717,7 @@
             <a:r>
               <a:rPr sz="1800" b="1">
                 <a:solidFill>
-                  <a:srgbClr val="22C55E"/>
+                  <a:srgbClr val="7FD6A6"/>
                 </a:solidFill>
                 <a:latin typeface="Segoe UI"/>
               </a:rPr>
@@ -5756,7 +5756,7 @@
             <a:r>
               <a:rPr sz="2800" b="1">
                 <a:solidFill>
-                  <a:srgbClr val="94A3B8"/>
+                  <a:srgbClr val="A4A4AC"/>
                 </a:solidFill>
                 <a:latin typeface="Segoe UI"/>
               </a:rPr>
@@ -5780,7 +5780,7 @@
             <a:avLst/>
           </a:prstGeom>
           <a:solidFill>
-            <a:srgbClr val="111726"/>
+            <a:srgbClr val="0F0F11"/>
           </a:solidFill>
           <a:ln w="12700">
             <a:solidFill>
@@ -5841,7 +5841,7 @@
             <a:r>
               <a:rPr sz="1800" b="1">
                 <a:solidFill>
-                  <a:srgbClr val="3B82F6"/>
+                  <a:srgbClr val="E0E0E5"/>
                 </a:solidFill>
                 <a:latin typeface="Segoe UI"/>
               </a:rPr>
@@ -5857,7 +5857,7 @@
             <a:r>
               <a:rPr sz="1800" b="1">
                 <a:solidFill>
-                  <a:srgbClr val="3B82F6"/>
+                  <a:srgbClr val="E0E0E5"/>
                 </a:solidFill>
                 <a:latin typeface="Segoe UI"/>
               </a:rPr>
@@ -5896,7 +5896,7 @@
             <a:r>
               <a:rPr sz="2800" b="1">
                 <a:solidFill>
-                  <a:srgbClr val="94A3B8"/>
+                  <a:srgbClr val="A4A4AC"/>
                 </a:solidFill>
                 <a:latin typeface="Segoe UI"/>
               </a:rPr>
@@ -5920,7 +5920,7 @@
             <a:avLst/>
           </a:prstGeom>
           <a:solidFill>
-            <a:srgbClr val="111726"/>
+            <a:srgbClr val="0F0F11"/>
           </a:solidFill>
           <a:ln w="12700">
             <a:solidFill>
@@ -5981,7 +5981,7 @@
             <a:r>
               <a:rPr sz="1800" b="1">
                 <a:solidFill>
-                  <a:srgbClr val="F59E0B"/>
+                  <a:srgbClr val="E0B448"/>
                 </a:solidFill>
                 <a:latin typeface="Segoe UI"/>
               </a:rPr>
@@ -5997,7 +5997,7 @@
             <a:r>
               <a:rPr sz="1800" b="1">
                 <a:solidFill>
-                  <a:srgbClr val="F59E0B"/>
+                  <a:srgbClr val="E0B448"/>
                 </a:solidFill>
                 <a:latin typeface="Segoe UI"/>
               </a:rPr>
@@ -6036,7 +6036,7 @@
             <a:r>
               <a:rPr sz="2800" b="1">
                 <a:solidFill>
-                  <a:srgbClr val="94A3B8"/>
+                  <a:srgbClr val="A4A4AC"/>
                 </a:solidFill>
                 <a:latin typeface="Segoe UI"/>
               </a:rPr>
@@ -6060,7 +6060,7 @@
             <a:avLst/>
           </a:prstGeom>
           <a:solidFill>
-            <a:srgbClr val="111726"/>
+            <a:srgbClr val="0F0F11"/>
           </a:solidFill>
           <a:ln w="12700">
             <a:solidFill>
@@ -6121,7 +6121,7 @@
             <a:r>
               <a:rPr sz="1800" b="1">
                 <a:solidFill>
-                  <a:srgbClr val="EF4444"/>
+                  <a:srgbClr val="F0613F"/>
                 </a:solidFill>
                 <a:latin typeface="Segoe UI"/>
               </a:rPr>
@@ -6137,7 +6137,7 @@
             <a:r>
               <a:rPr sz="1800" b="1">
                 <a:solidFill>
-                  <a:srgbClr val="EF4444"/>
+                  <a:srgbClr val="F0613F"/>
                 </a:solidFill>
                 <a:latin typeface="Segoe UI"/>
               </a:rPr>
@@ -6161,7 +6161,7 @@
             <a:avLst/>
           </a:prstGeom>
           <a:solidFill>
-            <a:srgbClr val="111726"/>
+            <a:srgbClr val="0F0F11"/>
           </a:solidFill>
           <a:ln w="12700">
             <a:solidFill>
@@ -6216,33 +6216,33 @@
           <a:p>
             <a:pPr algn="l">
               <a:lnSpc>
-                <a:spcPct val="125000"/>
+                <a:spcPct val="120000"/>
               </a:lnSpc>
             </a:pPr>
             <a:r>
-              <a:rPr sz="1800" b="0">
-                <a:solidFill>
-                  <a:srgbClr val="E5E9F0"/>
+              <a:rPr sz="1600" b="0">
+                <a:solidFill>
+                  <a:srgbClr val="FFFFFF"/>
                 </a:solidFill>
                 <a:latin typeface="Segoe UI"/>
               </a:rPr>
-              <a:t>We detect the manipulation STRUCTURE — urgency, impersonation, secrecy, irreversible payment — not keywords.</a:t>
+              <a:t>We detect the manipulation STRUCTURE — urgency, impersonation, secrecy, irreversible payment — not keywords. Works on any call, text, or chat, in any language, on any LLM.</a:t>
             </a:r>
           </a:p>
           <a:p>
             <a:pPr algn="l">
               <a:lnSpc>
-                <a:spcPct val="125000"/>
+                <a:spcPct val="120000"/>
               </a:lnSpc>
             </a:pPr>
             <a:r>
-              <a:rPr sz="1800" b="0">
-                <a:solidFill>
-                  <a:srgbClr val="E5E9F0"/>
+              <a:rPr sz="1600" b="0">
+                <a:solidFill>
+                  <a:srgbClr val="FFFFFF"/>
                 </a:solidFill>
                 <a:latin typeface="Segoe UI"/>
               </a:rPr>
-              <a:t>So it works on any call, text, or chat, in any language.</a:t>
+              <a:t>For real calls: a “Guardian Number” screens only UNKNOWN callers (family calls stay private), and can conference a loved one in and hold the call.</a:t>
             </a:r>
           </a:p>
         </p:txBody>
@@ -6280,7 +6280,7 @@
             <a:avLst/>
           </a:prstGeom>
           <a:solidFill>
-            <a:srgbClr val="0A0E1A"/>
+            <a:srgbClr val="000000"/>
           </a:solidFill>
           <a:ln>
             <a:noFill/>
@@ -6324,7 +6324,7 @@
             <a:avLst/>
           </a:prstGeom>
           <a:solidFill>
-            <a:srgbClr val="EF4444"/>
+            <a:srgbClr val="F0613F"/>
           </a:solidFill>
           <a:ln>
             <a:noFill/>
@@ -6353,7 +6353,7 @@
             <a:r>
               <a:rPr sz="2000" b="1">
                 <a:solidFill>
-                  <a:srgbClr val="E5E9F0"/>
+                  <a:srgbClr val="FFFFFF"/>
                 </a:solidFill>
                 <a:latin typeface="Segoe UI"/>
               </a:rPr>
@@ -6392,7 +6392,7 @@
             <a:r>
               <a:rPr sz="2600" b="1">
                 <a:solidFill>
-                  <a:srgbClr val="E5E9F0"/>
+                  <a:srgbClr val="FFFFFF"/>
                 </a:solidFill>
                 <a:latin typeface="Segoe UI"/>
               </a:rPr>
@@ -6431,7 +6431,7 @@
             <a:r>
               <a:rPr sz="1800" b="0">
                 <a:solidFill>
-                  <a:srgbClr val="94A3B8"/>
+                  <a:srgbClr val="A4A4AC"/>
                 </a:solidFill>
                 <a:latin typeface="Segoe UI"/>
               </a:rPr>
@@ -6473,7 +6473,7 @@
             <a:avLst/>
           </a:prstGeom>
           <a:solidFill>
-            <a:srgbClr val="0A0E1A"/>
+            <a:srgbClr val="000000"/>
           </a:solidFill>
           <a:ln>
             <a:noFill/>
@@ -6532,7 +6532,7 @@
             <a:r>
               <a:rPr sz="3000" b="1">
                 <a:solidFill>
-                  <a:srgbClr val="E5E9F0"/>
+                  <a:srgbClr val="FFFFFF"/>
                 </a:solidFill>
                 <a:latin typeface="Segoe UI"/>
               </a:rPr>
@@ -6556,7 +6556,7 @@
             <a:avLst/>
           </a:prstGeom>
           <a:solidFill>
-            <a:srgbClr val="111726"/>
+            <a:srgbClr val="0F0F11"/>
           </a:solidFill>
           <a:ln w="12700">
             <a:solidFill>
@@ -6617,7 +6617,7 @@
             <a:r>
               <a:rPr sz="2000" b="1">
                 <a:solidFill>
-                  <a:srgbClr val="3B82F6"/>
+                  <a:srgbClr val="E0E0E5"/>
                 </a:solidFill>
                 <a:latin typeface="Segoe UI"/>
               </a:rPr>
@@ -6656,7 +6656,7 @@
             <a:r>
               <a:rPr sz="1500" b="0">
                 <a:solidFill>
-                  <a:srgbClr val="94A3B8"/>
+                  <a:srgbClr val="A4A4AC"/>
                 </a:solidFill>
                 <a:latin typeface="Segoe UI"/>
               </a:rPr>
@@ -6680,7 +6680,7 @@
             <a:avLst/>
           </a:prstGeom>
           <a:solidFill>
-            <a:srgbClr val="111726"/>
+            <a:srgbClr val="0F0F11"/>
           </a:solidFill>
           <a:ln w="12700">
             <a:solidFill>
@@ -6741,7 +6741,7 @@
             <a:r>
               <a:rPr sz="2000" b="1">
                 <a:solidFill>
-                  <a:srgbClr val="22C55E"/>
+                  <a:srgbClr val="7FD6A6"/>
                 </a:solidFill>
                 <a:latin typeface="Segoe UI"/>
               </a:rPr>
@@ -6780,7 +6780,7 @@
             <a:r>
               <a:rPr sz="1500" b="0">
                 <a:solidFill>
-                  <a:srgbClr val="94A3B8"/>
+                  <a:srgbClr val="A4A4AC"/>
                 </a:solidFill>
                 <a:latin typeface="Segoe UI"/>
               </a:rPr>
@@ -6804,7 +6804,7 @@
             <a:avLst/>
           </a:prstGeom>
           <a:solidFill>
-            <a:srgbClr val="111726"/>
+            <a:srgbClr val="0F0F11"/>
           </a:solidFill>
           <a:ln w="12700">
             <a:solidFill>
@@ -6865,7 +6865,7 @@
             <a:r>
               <a:rPr sz="2000" b="1">
                 <a:solidFill>
-                  <a:srgbClr val="F59E0B"/>
+                  <a:srgbClr val="E0B448"/>
                 </a:solidFill>
                 <a:latin typeface="Segoe UI"/>
               </a:rPr>
@@ -6904,7 +6904,7 @@
             <a:r>
               <a:rPr sz="1500" b="0">
                 <a:solidFill>
-                  <a:srgbClr val="94A3B8"/>
+                  <a:srgbClr val="A4A4AC"/>
                 </a:solidFill>
                 <a:latin typeface="Segoe UI"/>
               </a:rPr>
@@ -6943,7 +6943,7 @@
             <a:r>
               <a:rPr sz="1800" b="1">
                 <a:solidFill>
-                  <a:srgbClr val="60A5FA"/>
+                  <a:srgbClr val="FFFFFF"/>
                 </a:solidFill>
                 <a:latin typeface="Segoe UI"/>
               </a:rPr>
@@ -6985,7 +6985,7 @@
             <a:avLst/>
           </a:prstGeom>
           <a:solidFill>
-            <a:srgbClr val="0A0E1A"/>
+            <a:srgbClr val="000000"/>
           </a:solidFill>
           <a:ln>
             <a:noFill/>
@@ -7044,7 +7044,7 @@
             <a:r>
               <a:rPr sz="3000" b="1">
                 <a:solidFill>
-                  <a:srgbClr val="E5E9F0"/>
+                  <a:srgbClr val="FFFFFF"/>
                 </a:solidFill>
                 <a:latin typeface="Segoe UI"/>
               </a:rPr>
@@ -7068,7 +7068,7 @@
             <a:avLst/>
           </a:prstGeom>
           <a:solidFill>
-            <a:srgbClr val="111726"/>
+            <a:srgbClr val="0F0F11"/>
           </a:solidFill>
           <a:ln w="12700">
             <a:solidFill>
@@ -7129,7 +7129,7 @@
             <a:r>
               <a:rPr sz="1800" b="1">
                 <a:solidFill>
-                  <a:srgbClr val="60A5FA"/>
+                  <a:srgbClr val="FFFFFF"/>
                 </a:solidFill>
                 <a:latin typeface="Segoe UI"/>
               </a:rPr>
@@ -7168,7 +7168,7 @@
             <a:r>
               <a:rPr sz="1700" b="0">
                 <a:solidFill>
-                  <a:srgbClr val="E5E9F0"/>
+                  <a:srgbClr val="FFFFFF"/>
                 </a:solidFill>
                 <a:latin typeface="Segoe UI"/>
               </a:rPr>
@@ -7192,7 +7192,7 @@
             <a:avLst/>
           </a:prstGeom>
           <a:solidFill>
-            <a:srgbClr val="111726"/>
+            <a:srgbClr val="0F0F11"/>
           </a:solidFill>
           <a:ln w="12700">
             <a:solidFill>
@@ -7253,7 +7253,7 @@
             <a:r>
               <a:rPr sz="1800" b="1">
                 <a:solidFill>
-                  <a:srgbClr val="60A5FA"/>
+                  <a:srgbClr val="FFFFFF"/>
                 </a:solidFill>
                 <a:latin typeface="Segoe UI"/>
               </a:rPr>
@@ -7292,7 +7292,7 @@
             <a:r>
               <a:rPr sz="1700" b="0">
                 <a:solidFill>
-                  <a:srgbClr val="E5E9F0"/>
+                  <a:srgbClr val="FFFFFF"/>
                 </a:solidFill>
                 <a:latin typeface="Segoe UI"/>
               </a:rPr>
@@ -7316,7 +7316,7 @@
             <a:avLst/>
           </a:prstGeom>
           <a:solidFill>
-            <a:srgbClr val="111726"/>
+            <a:srgbClr val="0F0F11"/>
           </a:solidFill>
           <a:ln w="12700">
             <a:solidFill>
@@ -7377,7 +7377,7 @@
             <a:r>
               <a:rPr sz="1800" b="1">
                 <a:solidFill>
-                  <a:srgbClr val="60A5FA"/>
+                  <a:srgbClr val="FFFFFF"/>
                 </a:solidFill>
                 <a:latin typeface="Segoe UI"/>
               </a:rPr>
@@ -7416,7 +7416,7 @@
             <a:r>
               <a:rPr sz="1700" b="0">
                 <a:solidFill>
-                  <a:srgbClr val="E5E9F0"/>
+                  <a:srgbClr val="FFFFFF"/>
                 </a:solidFill>
                 <a:latin typeface="Segoe UI"/>
               </a:rPr>
@@ -7455,7 +7455,7 @@
             <a:r>
               <a:rPr sz="1800" b="1">
                 <a:solidFill>
-                  <a:srgbClr val="22C55E"/>
+                  <a:srgbClr val="7FD6A6"/>
                 </a:solidFill>
                 <a:latin typeface="Segoe UI"/>
               </a:rPr>

</xml_diff>